<commit_message>
docs(jun25): real-data dashboard screenshot + presenters (Zuraiz + Kumaran)
- Captured a live screenshot of the dashboard on a real Dagstuhl piece
  (LI_QuartetA_Take02): real influence graph (S2/A1/B1/T1), real E(t)
  timeline, real metadata -> data/figures/wp4_dashboard_realdata.png.
- Fixed a stale 'mock data' label in TimelinePanel that persisted after
  the Phase-3 real-data wiring (the data was real; the title lied).
- Deck slide 6 + PPTX now use the real-data screenshot, not the Sprint-3
  mock scaffold image.
- Presenters set to Zuraiz and Kumaran Vasu (slide 1 + script).
PPTX re-rendered (8 slides). No em-dashes.
</commit_message>
<xml_diff>
--- a/output/jun25_status_meeting_v.pptx
+++ b/output/jun25_status_meeting_v.pptx
@@ -3228,7 +3228,7 @@
         </p:nvSpPr>
         <p:spPr>
           <a:xfrm>
-            <a:off x="502920" y="4572000"/>
+            <a:off x="502920" y="4480560"/>
             <a:ext cx="11185855" cy="365760"/>
           </a:xfrm>
           <a:prstGeom prst="rect">
@@ -3248,6 +3248,45 @@
               </a:lnSpc>
             </a:pPr>
             <a:r>
+              <a:rPr sz="1500" b="1">
+                <a:solidFill>
+                  <a:srgbClr val="FDFBF5"/>
+                </a:solidFill>
+                <a:latin typeface="Segoe UI"/>
+              </a:rPr>
+              <a:t>Presented by Zuraiz and Kumaran Vasu, on behalf of the team</a:t>
+            </a:r>
+          </a:p>
+        </p:txBody>
+      </p:sp>
+      <p:sp>
+        <p:nvSpPr>
+          <p:cNvPr id="6" name="TextBox 5"/>
+          <p:cNvSpPr txBox="1"/>
+          <p:nvPr/>
+        </p:nvSpPr>
+        <p:spPr>
+          <a:xfrm>
+            <a:off x="502920" y="5029200"/>
+            <a:ext cx="11185855" cy="365760"/>
+          </a:xfrm>
+          <a:prstGeom prst="rect">
+            <a:avLst/>
+          </a:prstGeom>
+          <a:noFill/>
+        </p:spPr>
+        <p:txBody>
+          <a:bodyPr wrap="square" anchor="t" lIns="27432" rIns="27432" tIns="18288" bIns="18288">
+            <a:spAutoFit/>
+          </a:bodyPr>
+          <a:lstStyle/>
+          <a:p>
+            <a:pPr algn="ctr" latinLnBrk="0">
+              <a:lnSpc>
+                <a:spcPct val="100000"/>
+              </a:lnSpc>
+            </a:pPr>
+            <a:r>
               <a:rPr sz="1300" b="0">
                 <a:solidFill>
                   <a:srgbClr val="CBD9DD"/>
@@ -3261,7 +3300,7 @@
       </p:sp>
       <p:sp>
         <p:nvSpPr>
-          <p:cNvPr id="6" name="TextBox 5"/>
+          <p:cNvPr id="7" name="TextBox 6"/>
           <p:cNvSpPr txBox="1"/>
           <p:nvPr/>
         </p:nvSpPr>
@@ -5305,7 +5344,7 @@
       </p:sp>
       <p:pic>
         <p:nvPicPr>
-          <p:cNvPr id="6" name="Picture 5" descr="wp4_dashboard_scaffold.png"/>
+          <p:cNvPr id="6" name="Picture 5" descr="wp4_dashboard_realdata.png"/>
           <p:cNvPicPr>
             <a:picLocks noChangeAspect="1"/>
           </p:cNvPicPr>
@@ -5319,8 +5358,8 @@
         </p:blipFill>
         <p:spPr>
           <a:xfrm>
-            <a:off x="1944130" y="1280160"/>
-            <a:ext cx="4615658" cy="4297680"/>
+            <a:off x="1933409" y="1280160"/>
+            <a:ext cx="4637101" cy="4297680"/>
           </a:xfrm>
           <a:prstGeom prst="rect">
             <a:avLst/>

</xml_diff>

<commit_message>
docs(jun25): drop questions-to-the-room; slide 8 = retrospective + open problems
Per review: the slide-8 questions were answerable by us, so asking them signalled
indecision. Replaced 'Questions for the room' with honest OPEN PROBLEMS (still
satisfies the rubric's problems/questions section):
- H1 rests on simulated latency (not live adaptation); real latency-varied
  recordings would test it directly.
- H3 visual still data-blocked; H2 topology not cleanly measured.
Slide 8 columns now What worked / What we fixed / Open problems; ends 'Thank you'.
Script + Q&A updated to match. PPTX re-rendered (8 slides). No em-dashes.
</commit_message>
<xml_diff>
--- a/output/jun25_status_meeting_v.pptx
+++ b/output/jun25_status_meeting_v.pptx
@@ -5797,7 +5797,7 @@
                 </a:solidFill>
                 <a:latin typeface="Segoe UI"/>
               </a:rPr>
-              <a:t>Finish cross-dataset corpus; per-window time-varying networks</a:t>
+              <a:t>Per-window time-varying networks; cleaner H2 topology measure</a:t>
             </a:r>
           </a:p>
         </p:txBody>
@@ -5857,7 +5857,7 @@
                 </a:solidFill>
                 <a:latin typeface="Segoe UI Semibold"/>
               </a:rPr>
-              <a:t>WP2</a:t>
+              <a:t>Paper</a:t>
             </a:r>
           </a:p>
           <a:p>
@@ -5873,7 +5873,7 @@
                 </a:solidFill>
                 <a:latin typeface="Segoe UI"/>
               </a:rPr>
-              <a:t>Pose on all 29 Tier-1 videos (visibility-triaged)</a:t>
+              <a:t>Draft report methods + results (the latency finding)</a:t>
             </a:r>
           </a:p>
         </p:txBody>
@@ -5933,7 +5933,7 @@
                 </a:solidFill>
                 <a:latin typeface="Segoe UI Semibold"/>
               </a:rPr>
-              <a:t>Paper</a:t>
+              <a:t>WP2 / H3</a:t>
             </a:r>
           </a:p>
           <a:p>
@@ -5949,7 +5949,7 @@
                 </a:solidFill>
                 <a:latin typeface="Segoe UI"/>
               </a:rPr>
-              <a:t>Draft report methods + results (the latency finding)</a:t>
+              <a:t>First visual-onset V(t): pair pose onsets with audio onsets on the 18 usable Tier-1 videos</a:t>
             </a:r>
           </a:p>
         </p:txBody>
@@ -5957,82 +5957,6 @@
       <p:sp>
         <p:nvSpPr>
           <p:cNvPr id="10" name="Rounded Rectangle 9"/>
-          <p:cNvSpPr/>
-          <p:nvPr/>
-        </p:nvSpPr>
-        <p:spPr>
-          <a:xfrm>
-            <a:off x="502920" y="4828032"/>
-            <a:ext cx="11185855" cy="749808"/>
-          </a:xfrm>
-          <a:prstGeom prst="roundRect">
-            <a:avLst>
-              <a:gd name="adj" fmla="val 4000"/>
-            </a:avLst>
-          </a:prstGeom>
-          <a:solidFill>
-            <a:srgbClr val="FDFBF5"/>
-          </a:solidFill>
-          <a:ln w="12700">
-            <a:solidFill>
-              <a:srgbClr val="CBD9DD"/>
-            </a:solidFill>
-          </a:ln>
-        </p:spPr>
-        <p:style>
-          <a:lnRef idx="1">
-            <a:schemeClr val="accent1"/>
-          </a:lnRef>
-          <a:fillRef idx="3">
-            <a:schemeClr val="accent1"/>
-          </a:fillRef>
-          <a:effectRef idx="2">
-            <a:schemeClr val="accent1"/>
-          </a:effectRef>
-          <a:fontRef idx="minor">
-            <a:schemeClr val="lt1"/>
-          </a:fontRef>
-        </p:style>
-        <p:txBody>
-          <a:bodyPr rtlCol="0" anchor="t" wrap="square" lIns="201168" rIns="201168" tIns="146304"/>
-          <a:lstStyle/>
-          <a:p>
-            <a:pPr algn="l" latinLnBrk="0">
-              <a:spcAft>
-                <a:spcPts val="600"/>
-              </a:spcAft>
-            </a:pPr>
-            <a:r>
-              <a:rPr sz="1400" b="1">
-                <a:solidFill>
-                  <a:srgbClr val="0E4D5E"/>
-                </a:solidFill>
-                <a:latin typeface="Segoe UI Semibold"/>
-              </a:rPr>
-              <a:t>Compute</a:t>
-            </a:r>
-          </a:p>
-          <a:p>
-            <a:pPr algn="l" latinLnBrk="0">
-              <a:spcAft>
-                <a:spcPts val="400"/>
-              </a:spcAft>
-            </a:pPr>
-            <a:r>
-              <a:rPr sz="1250" b="0">
-                <a:solidFill>
-                  <a:srgbClr val="24262E"/>
-                </a:solidFill>
-                <a:latin typeface="Segoe UI"/>
-              </a:rPr>
-              <a:t>Cluster access for the paper-scale run (2000-shuffle null)</a:t>
-            </a:r>
-          </a:p>
-        </p:txBody>
-      </p:sp>
-      <p:sp>
-        <p:nvSpPr>
-          <p:cNvPr id="11" name="Rounded Rectangle 10"/>
           <p:cNvSpPr/>
           <p:nvPr/>
         </p:nvSpPr>
@@ -6144,7 +6068,7 @@
                 </a:solidFill>
                 <a:latin typeface="Segoe UI Semibold"/>
               </a:rPr>
-              <a:t>RETROSPECTIVE · QUESTIONS</a:t>
+              <a:t>RETROSPECTIVE · OPEN PROBLEMS</a:t>
             </a:r>
           </a:p>
         </p:txBody>
@@ -6183,7 +6107,7 @@
                 </a:solidFill>
                 <a:latin typeface="Segoe UI Semibold"/>
               </a:rPr>
-              <a:t>Retrospective and open questions</a:t>
+              <a:t>Retrospective and open problems</a:t>
             </a:r>
           </a:p>
         </p:txBody>
@@ -6429,7 +6353,7 @@
                 </a:solidFill>
                 <a:latin typeface="Segoe UI Semibold"/>
               </a:rPr>
-              <a:t>Limitations</a:t>
+              <a:t>What we fixed</a:t>
             </a:r>
           </a:p>
           <a:p>
@@ -6445,7 +6369,7 @@
                 </a:solidFill>
                 <a:latin typeface="Segoe UI"/>
               </a:rPr>
-              <a:t>Injection tests transmission timing, not a live singer's adaptation.</a:t>
+              <a:t>The stale 'ESMUC proprietary' note: it is open on Zenodo, and we used it.</a:t>
             </a:r>
           </a:p>
           <a:p>
@@ -6477,7 +6401,7 @@
                 </a:solidFill>
                 <a:latin typeface="Segoe UI"/>
               </a:rPr>
-              <a:t>Envelope E(t) alone is latency-blind (why onset synchrony matters).</a:t>
+              <a:t>Curation now filters on singer visibility, not just NMP regime.</a:t>
             </a:r>
           </a:p>
         </p:txBody>
@@ -6537,7 +6461,7 @@
                 </a:solidFill>
                 <a:latin typeface="Segoe UI Semibold"/>
               </a:rPr>
-              <a:t>Questions</a:t>
+              <a:t>Open problems</a:t>
             </a:r>
           </a:p>
           <a:p>
@@ -6553,7 +6477,7 @@
                 </a:solidFill>
                 <a:latin typeface="Segoe UI"/>
               </a:rPr>
-              <a:t>Hacker: foreground onset synchrony over composite E(t) in the report?</a:t>
+              <a:t>H1 rests on simulated latency (transmission delay, not live adaptation); real latency-varied recordings would test it directly.</a:t>
             </a:r>
           </a:p>
           <a:p>
@@ -6585,7 +6509,7 @@
                 </a:solidFill>
                 <a:latin typeface="Segoe UI"/>
               </a:rPr>
-              <a:t>Coordinators: cluster access for the paper-scale run (ki-support contacted)?</a:t>
+              <a:t>H3 visual still data-blocked; H2 topology not cleanly measured yet.</a:t>
             </a:r>
           </a:p>
         </p:txBody>

</xml_diff>